<commit_message>
docs: add Prefill activation and expert HBM breakdown
Co-authored-by: 69515164-rgb <69515164-rgb@users.noreply.github.com>
</commit_message>
<xml_diff>
--- a/docs/deepseek-96g-256p-slo.pptx
+++ b/docs/deepseek-96g-256p-slo.pptx
@@ -159,7 +159,7 @@
             <c:idx val="1"/>
             <c:spPr>
               <a:solidFill>
-                <a:srgbClr val="7A541C"/>
+                <a:srgbClr val="145A96"/>
               </a:solidFill>
               <a:ln>
                 <a:solidFill>
@@ -172,6 +172,32 @@
             <c:idx val="2"/>
             <c:spPr>
               <a:solidFill>
+                <a:srgbClr val="7A4EAB"/>
+              </a:solidFill>
+              <a:ln>
+                <a:solidFill>
+                  <a:srgbClr val="FFFFFF"/>
+                </a:solidFill>
+              </a:ln>
+            </c:spPr>
+          </c:dPt>
+          <c:dPt>
+            <c:idx val="3"/>
+            <c:spPr>
+              <a:solidFill>
+                <a:srgbClr val="7A541C"/>
+              </a:solidFill>
+              <a:ln>
+                <a:solidFill>
+                  <a:srgbClr val="FFFFFF"/>
+                </a:solidFill>
+              </a:ln>
+            </c:spPr>
+          </c:dPt>
+          <c:dPt>
+            <c:idx val="4"/>
+            <c:spPr>
+              <a:solidFill>
                 <a:srgbClr val="0E7A76"/>
               </a:solidFill>
               <a:ln>
@@ -182,7 +208,7 @@
             </c:spPr>
           </c:dPt>
           <c:dPt>
-            <c:idx val="3"/>
+            <c:idx val="5"/>
             <c:spPr>
               <a:solidFill>
                 <a:srgbClr val="DCE3E9"/>
@@ -196,19 +222,25 @@
           </c:dPt>
           <c:cat>
             <c:strRef>
-              <c:f>Sheet1!$A$2:$A$5</c:f>
+              <c:f>Sheet1!$A$2:$A$7</c:f>
               <c:strCache>
-                <c:ptCount val="4"/>
+                <c:ptCount val="6"/>
                 <c:pt idx="0">
-                  <c:v>模型权重</c:v>
+                  <c:v>专家权重</c:v>
                 </c:pt>
                 <c:pt idx="1">
+                  <c:v>Attention权重</c:v>
+                </c:pt>
+                <c:pt idx="2">
+                  <c:v>激活/workspace</c:v>
+                </c:pt>
+                <c:pt idx="3">
                   <c:v>系统预留</c:v>
                 </c:pt>
-                <c:pt idx="2">
+                <c:pt idx="4">
                   <c:v>KV cache</c:v>
                 </c:pt>
-                <c:pt idx="3">
+                <c:pt idx="5">
                   <c:v>空闲</c:v>
                 </c:pt>
               </c:strCache>
@@ -216,21 +248,27 @@
           </c:cat>
           <c:val>
             <c:numRef>
-              <c:f>Sheet1!$B$2:$B$5</c:f>
+              <c:f>Sheet1!$B$2:$B$7</c:f>
               <c:numCache>
                 <c:formatCode>General</c:formatCode>
-                <c:ptCount val="4"/>
+                <c:ptCount val="6"/>
                 <c:pt idx="0">
-                  <c:v>25.880603184</c:v>
+                  <c:v>23.461853184</c:v>
                 </c:pt>
                 <c:pt idx="1">
+                  <c:v>2.41875</c:v>
+                </c:pt>
+                <c:pt idx="2">
+                  <c:v>0.469762048</c:v>
+                </c:pt>
+                <c:pt idx="3">
                   <c:v>6.0</c:v>
                 </c:pt>
-                <c:pt idx="2">
+                <c:pt idx="4">
                   <c:v>8.825376</c:v>
                 </c:pt>
-                <c:pt idx="3">
-                  <c:v>55.29402081600001</c:v>
+                <c:pt idx="5">
+                  <c:v>54.824258768</c:v>
                 </c:pt>
               </c:numCache>
             </c:numRef>
@@ -320,7 +358,7 @@
             <c:idx val="1"/>
             <c:spPr>
               <a:solidFill>
-                <a:srgbClr val="7A541C"/>
+                <a:srgbClr val="145A96"/>
               </a:solidFill>
               <a:ln>
                 <a:solidFill>
@@ -333,6 +371,32 @@
             <c:idx val="2"/>
             <c:spPr>
               <a:solidFill>
+                <a:srgbClr val="7A4EAB"/>
+              </a:solidFill>
+              <a:ln>
+                <a:solidFill>
+                  <a:srgbClr val="FFFFFF"/>
+                </a:solidFill>
+              </a:ln>
+            </c:spPr>
+          </c:dPt>
+          <c:dPt>
+            <c:idx val="3"/>
+            <c:spPr>
+              <a:solidFill>
+                <a:srgbClr val="7A541C"/>
+              </a:solidFill>
+              <a:ln>
+                <a:solidFill>
+                  <a:srgbClr val="FFFFFF"/>
+                </a:solidFill>
+              </a:ln>
+            </c:spPr>
+          </c:dPt>
+          <c:dPt>
+            <c:idx val="4"/>
+            <c:spPr>
+              <a:solidFill>
                 <a:srgbClr val="0E7A76"/>
               </a:solidFill>
               <a:ln>
@@ -343,7 +407,7 @@
             </c:spPr>
           </c:dPt>
           <c:dPt>
-            <c:idx val="3"/>
+            <c:idx val="5"/>
             <c:spPr>
               <a:solidFill>
                 <a:srgbClr val="DCE3E9"/>
@@ -357,19 +421,25 @@
           </c:dPt>
           <c:cat>
             <c:strRef>
-              <c:f>Sheet1!$A$2:$A$5</c:f>
+              <c:f>Sheet1!$A$2:$A$7</c:f>
               <c:strCache>
-                <c:ptCount val="4"/>
+                <c:ptCount val="6"/>
                 <c:pt idx="0">
-                  <c:v>模型权重</c:v>
+                  <c:v>专家权重</c:v>
                 </c:pt>
                 <c:pt idx="1">
+                  <c:v>Attention权重</c:v>
+                </c:pt>
+                <c:pt idx="2">
+                  <c:v>激活/workspace</c:v>
+                </c:pt>
+                <c:pt idx="3">
                   <c:v>系统预留</c:v>
                 </c:pt>
-                <c:pt idx="2">
+                <c:pt idx="4">
                   <c:v>KV cache</c:v>
                 </c:pt>
-                <c:pt idx="3">
+                <c:pt idx="5">
                   <c:v>空闲</c:v>
                 </c:pt>
               </c:strCache>
@@ -377,21 +447,27 @@
           </c:cat>
           <c:val>
             <c:numRef>
-              <c:f>Sheet1!$B$2:$B$5</c:f>
+              <c:f>Sheet1!$B$2:$B$7</c:f>
               <c:numCache>
                 <c:formatCode>General</c:formatCode>
-                <c:ptCount val="4"/>
+                <c:ptCount val="6"/>
                 <c:pt idx="0">
-                  <c:v>25.880603184</c:v>
+                  <c:v>23.461853184</c:v>
                 </c:pt>
                 <c:pt idx="1">
+                  <c:v>2.41875</c:v>
+                </c:pt>
+                <c:pt idx="2">
+                  <c:v>0.469762048</c:v>
+                </c:pt>
+                <c:pt idx="3">
                   <c:v>6.0</c:v>
                 </c:pt>
-                <c:pt idx="2">
+                <c:pt idx="4">
                   <c:v>5.197430784</c:v>
                 </c:pt>
-                <c:pt idx="3">
-                  <c:v>58.92196603200001</c:v>
+                <c:pt idx="5">
+                  <c:v>58.452203984</c:v>
                 </c:pt>
               </c:numCache>
             </c:numRef>
@@ -481,7 +557,7 @@
             <c:idx val="1"/>
             <c:spPr>
               <a:solidFill>
-                <a:srgbClr val="7A541C"/>
+                <a:srgbClr val="145A96"/>
               </a:solidFill>
               <a:ln>
                 <a:solidFill>
@@ -494,6 +570,32 @@
             <c:idx val="2"/>
             <c:spPr>
               <a:solidFill>
+                <a:srgbClr val="7A4EAB"/>
+              </a:solidFill>
+              <a:ln>
+                <a:solidFill>
+                  <a:srgbClr val="FFFFFF"/>
+                </a:solidFill>
+              </a:ln>
+            </c:spPr>
+          </c:dPt>
+          <c:dPt>
+            <c:idx val="3"/>
+            <c:spPr>
+              <a:solidFill>
+                <a:srgbClr val="7A541C"/>
+              </a:solidFill>
+              <a:ln>
+                <a:solidFill>
+                  <a:srgbClr val="FFFFFF"/>
+                </a:solidFill>
+              </a:ln>
+            </c:spPr>
+          </c:dPt>
+          <c:dPt>
+            <c:idx val="4"/>
+            <c:spPr>
+              <a:solidFill>
                 <a:srgbClr val="0E7A76"/>
               </a:solidFill>
               <a:ln>
@@ -504,7 +606,7 @@
             </c:spPr>
           </c:dPt>
           <c:dPt>
-            <c:idx val="3"/>
+            <c:idx val="5"/>
             <c:spPr>
               <a:solidFill>
                 <a:srgbClr val="DCE3E9"/>
@@ -518,19 +620,25 @@
           </c:dPt>
           <c:cat>
             <c:strRef>
-              <c:f>Sheet1!$A$2:$A$5</c:f>
+              <c:f>Sheet1!$A$2:$A$7</c:f>
               <c:strCache>
-                <c:ptCount val="4"/>
+                <c:ptCount val="6"/>
                 <c:pt idx="0">
-                  <c:v>模型权重</c:v>
+                  <c:v>专家权重</c:v>
                 </c:pt>
                 <c:pt idx="1">
+                  <c:v>Attention权重</c:v>
+                </c:pt>
+                <c:pt idx="2">
+                  <c:v>激活/workspace</c:v>
+                </c:pt>
+                <c:pt idx="3">
                   <c:v>系统预留</c:v>
                 </c:pt>
-                <c:pt idx="2">
+                <c:pt idx="4">
                   <c:v>KV cache</c:v>
                 </c:pt>
-                <c:pt idx="3">
+                <c:pt idx="5">
                   <c:v>空闲</c:v>
                 </c:pt>
               </c:strCache>
@@ -538,21 +646,27 @@
           </c:cat>
           <c:val>
             <c:numRef>
-              <c:f>Sheet1!$B$2:$B$5</c:f>
+              <c:f>Sheet1!$B$2:$B$7</c:f>
               <c:numCache>
                 <c:formatCode>General</c:formatCode>
-                <c:ptCount val="4"/>
+                <c:ptCount val="6"/>
                 <c:pt idx="0">
-                  <c:v>25.880603184</c:v>
+                  <c:v>23.461853184</c:v>
                 </c:pt>
                 <c:pt idx="1">
+                  <c:v>2.41875</c:v>
+                </c:pt>
+                <c:pt idx="2">
+                  <c:v>0.469762048</c:v>
+                </c:pt>
+                <c:pt idx="3">
                   <c:v>6.0</c:v>
                 </c:pt>
-                <c:pt idx="2">
+                <c:pt idx="4">
                   <c:v>2.59196928</c:v>
                 </c:pt>
-                <c:pt idx="3">
-                  <c:v>61.527427536000005</c:v>
+                <c:pt idx="5">
+                  <c:v>61.057665488</c:v>
                 </c:pt>
               </c:numCache>
             </c:numRef>
@@ -704,7 +818,7 @@
                 <c:formatCode>General</c:formatCode>
                 <c:ptCount val="4"/>
                 <c:pt idx="0">
-                  <c:v>25.880603184</c:v>
+                  <c:v>25.880603183999998</c:v>
                 </c:pt>
                 <c:pt idx="1">
                   <c:v>6.0</c:v>
@@ -865,7 +979,7 @@
                 <c:formatCode>General</c:formatCode>
                 <c:ptCount val="4"/>
                 <c:pt idx="0">
-                  <c:v>25.880603184</c:v>
+                  <c:v>25.880603183999998</c:v>
                 </c:pt>
                 <c:pt idx="1">
                   <c:v>6.0</c:v>
@@ -1026,7 +1140,7 @@
                 <c:formatCode>General</c:formatCode>
                 <c:ptCount val="4"/>
                 <c:pt idx="0">
-                  <c:v>25.880603184</c:v>
+                  <c:v>25.880603183999998</c:v>
                 </c:pt>
                 <c:pt idx="1">
                   <c:v>6.0</c:v>
@@ -1691,7 +1805,7 @@
           <a:lstStyle/>
           <a:p>
             <a:r>
-              <a:t>饼图按最忙活跃GPU，不按256卡平均。每卡固定：路由专家19.432 GB，共享专家4.030 GB，Attention 2.419 GB，系统预留6 GB。KV=ceil(BS/32)×store_seq(S)/8。4K: BS=91348, kv=8.825GB, free=55.294GB. 256K: BS=996, kv=5.197GB, free=58.922GB. 1M: BS=128, kv=2.592GB, free=61.527GB.</a:t>
+              <a:t>饼图按最忙活跃GPU，不按256卡平均。每卡固定：路由专家19.432 GB，共享专家4.030 GB，Attention 2.419 GB，系统预留6 GB。KV=ceil(BS/32)×store_seq(S)/8。激活按8K query chunk、4个BF16 hidden等价buffer估算，包含Attention/MoE/collective活跃临时区，不代表框架峰值实测。4K: BS=91348, act=0.470GB, kv=8.825GB, free=54.824GB. 256K: BS=996, act=0.470GB, kv=5.197GB, free=58.452GB. 1M: BS=128, act=0.470GB, kv=2.592GB, free=61.058GB.</a:t>
             </a:r>
           </a:p>
         </p:txBody>
@@ -12170,7 +12284,7 @@
                 <a:ea typeface="Microsoft YaHei"/>
                 <a:cs typeface="Microsoft YaHei"/>
               </a:rPr>
-              <a:t>Prefill：输入变长后，时间摸高批下降，单卡 KV 占用仍小</a:t>
+              <a:t>Prefill：专家权重、Attention权重和激活分别计入 HBM</a:t>
             </a:r>
           </a:p>
         </p:txBody>
@@ -12382,7 +12496,7 @@
                 <a:ea typeface="Microsoft YaHei"/>
                 <a:cs typeface="Microsoft YaHei"/>
               </a:rPr>
-              <a:t>每个饼是最忙活跃卡的 96 GB HBM。模型权重固定 45.31 GB，系统预留 6 GB；prefix 经参数面拉入 HBM。</a:t>
+              <a:t>每个饼是最忙活跃卡：专家权重23.46 GB，Attention权重2.42 GB；激活按8K query chunk、4个BF16 hidden等价缓冲区。</a:t>
             </a:r>
           </a:p>
         </p:txBody>
@@ -12484,7 +12598,7 @@
                 <a:ea typeface="Microsoft YaHei"/>
                 <a:cs typeface="Microsoft YaHei"/>
               </a:rPr>
-              <a:t>BS 91348    权重 25.88 GB    预留 6 GB</a:t>
+              <a:t>BS 91348  专家 23.46 GB  Attention 2.42 GB</a:t>
             </a:r>
           </a:p>
           <a:p>
@@ -12505,7 +12619,7 @@
                 <a:ea typeface="Microsoft YaHei"/>
                 <a:cs typeface="Microsoft YaHei"/>
               </a:rPr>
-              <a:t>HBM KV 8.83 GB  ｜  空闲 55.29 GB</a:t>
+              <a:t>激活 0.47 GB  ｜  KV 8.83 GB  ｜  空闲 54.82 GB</a:t>
             </a:r>
           </a:p>
         </p:txBody>
@@ -12649,7 +12763,7 @@
                 <a:ea typeface="Microsoft YaHei"/>
                 <a:cs typeface="Microsoft YaHei"/>
               </a:rPr>
-              <a:t>BS 996    权重 25.88 GB    预留 6 GB</a:t>
+              <a:t>BS 996  专家 23.46 GB  Attention 2.42 GB</a:t>
             </a:r>
           </a:p>
           <a:p>
@@ -12670,7 +12784,7 @@
                 <a:ea typeface="Microsoft YaHei"/>
                 <a:cs typeface="Microsoft YaHei"/>
               </a:rPr>
-              <a:t>HBM KV 5.20 GB  ｜  空闲 58.92 GB</a:t>
+              <a:t>激活 0.47 GB  ｜  KV 5.20 GB  ｜  空闲 58.45 GB</a:t>
             </a:r>
           </a:p>
         </p:txBody>
@@ -12814,7 +12928,7 @@
                 <a:ea typeface="Microsoft YaHei"/>
                 <a:cs typeface="Microsoft YaHei"/>
               </a:rPr>
-              <a:t>BS 128    权重 25.88 GB    预留 6 GB</a:t>
+              <a:t>BS 128  专家 23.46 GB  Attention 2.42 GB</a:t>
             </a:r>
           </a:p>
           <a:p>
@@ -12835,7 +12949,7 @@
                 <a:ea typeface="Microsoft YaHei"/>
                 <a:cs typeface="Microsoft YaHei"/>
               </a:rPr>
-              <a:t>HBM KV 2.59 GB  ｜  空闲 61.53 GB</a:t>
+              <a:t>激活 0.47 GB  ｜  KV 2.59 GB  ｜  空闲 61.06 GB</a:t>
             </a:r>
           </a:p>
         </p:txBody>
@@ -12962,7 +13076,7 @@
                 <a:ea typeface="Microsoft YaHei"/>
                 <a:cs typeface="Microsoft YaHei"/>
               </a:rPr>
-              <a:t>Prefill 的长输入先被 TTFT 限制：4K / 256K / 1M 的最大批分别是 91348 / 996 / 128，最忙卡 HBM KV 只有 8.83 / 5.20 / 2.59 GB，均不需要 DDR 池。</a:t>
+              <a:t>激活/workspace估算为4×min(query rows, 8192)×7168×2字节，三档均为0.47 GB。这是流水实现的活跃集，不乘61层；若不做query chunk，4K摸高批的单个hidden张量约3.35 GB，不能沿用本图。</a:t>
             </a:r>
           </a:p>
         </p:txBody>

</xml_diff>

<commit_message>
docs: clarify Prefill HBM pie labels
Co-authored-by: 69515164-rgb <69515164-rgb@users.noreply.github.com>
</commit_message>
<xml_diff>
--- a/docs/deepseek-96g-256p-slo.pptx
+++ b/docs/deepseek-96g-256p-slo.pptx
@@ -293,7 +293,7 @@
           <c:dLblPos val="outEnd"/>
           <c:showLegendKey val="0"/>
           <c:showVal val="0"/>
-          <c:showCatName val="1"/>
+          <c:showCatName val="0"/>
           <c:showSerName val="0"/>
           <c:showPercent val="1"/>
           <c:showBubbleSize val="0"/>
@@ -492,7 +492,7 @@
           <c:dLblPos val="outEnd"/>
           <c:showLegendKey val="0"/>
           <c:showVal val="0"/>
-          <c:showCatName val="1"/>
+          <c:showCatName val="0"/>
           <c:showSerName val="0"/>
           <c:showPercent val="1"/>
           <c:showBubbleSize val="0"/>
@@ -691,7 +691,7 @@
           <c:dLblPos val="outEnd"/>
           <c:showLegendKey val="0"/>
           <c:showVal val="0"/>
-          <c:showCatName val="1"/>
+          <c:showCatName val="0"/>
           <c:showSerName val="0"/>
           <c:showPercent val="1"/>
           <c:showBubbleSize val="0"/>
@@ -12569,8 +12569,8 @@
         </p:nvSpPr>
         <p:spPr>
           <a:xfrm>
-            <a:off x="384048" y="4681728"/>
-            <a:ext cx="3529584" cy="530352"/>
+            <a:off x="384048" y="4608576"/>
+            <a:ext cx="3529584" cy="658368"/>
           </a:xfrm>
           <a:prstGeom prst="rect">
             <a:avLst/>
@@ -12590,7 +12590,7 @@
               </a:spcAft>
             </a:pPr>
             <a:r>
-              <a:rPr sz="1100" b="0">
+              <a:rPr sz="1000" b="0">
                 <a:solidFill>
                   <a:srgbClr val="1C242E"/>
                 </a:solidFill>
@@ -12598,7 +12598,7 @@
                 <a:ea typeface="Microsoft YaHei"/>
                 <a:cs typeface="Microsoft YaHei"/>
               </a:rPr>
-              <a:t>BS 91348  专家 23.46 GB  Attention 2.42 GB</a:t>
+              <a:t>BS 91348</a:t>
             </a:r>
           </a:p>
           <a:p>
@@ -12611,7 +12611,7 @@
               </a:spcAft>
             </a:pPr>
             <a:r>
-              <a:rPr sz="1100" b="0">
+              <a:rPr sz="1000" b="0">
                 <a:solidFill>
                   <a:srgbClr val="1C242E"/>
                 </a:solidFill>
@@ -12619,7 +12619,28 @@
                 <a:ea typeface="Microsoft YaHei"/>
                 <a:cs typeface="Microsoft YaHei"/>
               </a:rPr>
-              <a:t>激活 0.47 GB  ｜  KV 8.83 GB  ｜  空闲 54.82 GB</a:t>
+              <a:t>专家 23.46  Attention 2.42  激活 0.47 GB</a:t>
+            </a:r>
+          </a:p>
+          <a:p>
+            <a:pPr algn="ctr">
+              <a:spcBef>
+                <a:spcPts val="0"/>
+              </a:spcBef>
+              <a:spcAft>
+                <a:spcPts val="0"/>
+              </a:spcAft>
+            </a:pPr>
+            <a:r>
+              <a:rPr sz="1000" b="0">
+                <a:solidFill>
+                  <a:srgbClr val="1C242E"/>
+                </a:solidFill>
+                <a:latin typeface="Microsoft YaHei"/>
+                <a:ea typeface="Microsoft YaHei"/>
+                <a:cs typeface="Microsoft YaHei"/>
+              </a:rPr>
+              <a:t>预留 6  KV 8.83  空闲 54.82 GB</a:t>
             </a:r>
           </a:p>
         </p:txBody>
@@ -12734,8 +12755,8 @@
         </p:nvSpPr>
         <p:spPr>
           <a:xfrm>
-            <a:off x="4315968" y="4681728"/>
-            <a:ext cx="3529584" cy="530352"/>
+            <a:off x="4315968" y="4608576"/>
+            <a:ext cx="3529584" cy="658368"/>
           </a:xfrm>
           <a:prstGeom prst="rect">
             <a:avLst/>
@@ -12755,7 +12776,7 @@
               </a:spcAft>
             </a:pPr>
             <a:r>
-              <a:rPr sz="1100" b="0">
+              <a:rPr sz="1000" b="0">
                 <a:solidFill>
                   <a:srgbClr val="1C242E"/>
                 </a:solidFill>
@@ -12763,7 +12784,7 @@
                 <a:ea typeface="Microsoft YaHei"/>
                 <a:cs typeface="Microsoft YaHei"/>
               </a:rPr>
-              <a:t>BS 996  专家 23.46 GB  Attention 2.42 GB</a:t>
+              <a:t>BS 996</a:t>
             </a:r>
           </a:p>
           <a:p>
@@ -12776,7 +12797,7 @@
               </a:spcAft>
             </a:pPr>
             <a:r>
-              <a:rPr sz="1100" b="0">
+              <a:rPr sz="1000" b="0">
                 <a:solidFill>
                   <a:srgbClr val="1C242E"/>
                 </a:solidFill>
@@ -12784,7 +12805,28 @@
                 <a:ea typeface="Microsoft YaHei"/>
                 <a:cs typeface="Microsoft YaHei"/>
               </a:rPr>
-              <a:t>激活 0.47 GB  ｜  KV 5.20 GB  ｜  空闲 58.45 GB</a:t>
+              <a:t>专家 23.46  Attention 2.42  激活 0.47 GB</a:t>
+            </a:r>
+          </a:p>
+          <a:p>
+            <a:pPr algn="ctr">
+              <a:spcBef>
+                <a:spcPts val="0"/>
+              </a:spcBef>
+              <a:spcAft>
+                <a:spcPts val="0"/>
+              </a:spcAft>
+            </a:pPr>
+            <a:r>
+              <a:rPr sz="1000" b="0">
+                <a:solidFill>
+                  <a:srgbClr val="1C242E"/>
+                </a:solidFill>
+                <a:latin typeface="Microsoft YaHei"/>
+                <a:ea typeface="Microsoft YaHei"/>
+                <a:cs typeface="Microsoft YaHei"/>
+              </a:rPr>
+              <a:t>预留 6  KV 5.20  空闲 58.45 GB</a:t>
             </a:r>
           </a:p>
         </p:txBody>
@@ -12899,8 +12941,8 @@
         </p:nvSpPr>
         <p:spPr>
           <a:xfrm>
-            <a:off x="8247888" y="4681728"/>
-            <a:ext cx="3529584" cy="530352"/>
+            <a:off x="8247888" y="4608576"/>
+            <a:ext cx="3529584" cy="658368"/>
           </a:xfrm>
           <a:prstGeom prst="rect">
             <a:avLst/>
@@ -12920,7 +12962,7 @@
               </a:spcAft>
             </a:pPr>
             <a:r>
-              <a:rPr sz="1100" b="0">
+              <a:rPr sz="1000" b="0">
                 <a:solidFill>
                   <a:srgbClr val="1C242E"/>
                 </a:solidFill>
@@ -12928,7 +12970,7 @@
                 <a:ea typeface="Microsoft YaHei"/>
                 <a:cs typeface="Microsoft YaHei"/>
               </a:rPr>
-              <a:t>BS 128  专家 23.46 GB  Attention 2.42 GB</a:t>
+              <a:t>BS 128</a:t>
             </a:r>
           </a:p>
           <a:p>
@@ -12941,7 +12983,7 @@
               </a:spcAft>
             </a:pPr>
             <a:r>
-              <a:rPr sz="1100" b="0">
+              <a:rPr sz="1000" b="0">
                 <a:solidFill>
                   <a:srgbClr val="1C242E"/>
                 </a:solidFill>
@@ -12949,7 +12991,28 @@
                 <a:ea typeface="Microsoft YaHei"/>
                 <a:cs typeface="Microsoft YaHei"/>
               </a:rPr>
-              <a:t>激活 0.47 GB  ｜  KV 2.59 GB  ｜  空闲 61.06 GB</a:t>
+              <a:t>专家 23.46  Attention 2.42  激活 0.47 GB</a:t>
+            </a:r>
+          </a:p>
+          <a:p>
+            <a:pPr algn="ctr">
+              <a:spcBef>
+                <a:spcPts val="0"/>
+              </a:spcBef>
+              <a:spcAft>
+                <a:spcPts val="0"/>
+              </a:spcAft>
+            </a:pPr>
+            <a:r>
+              <a:rPr sz="1000" b="0">
+                <a:solidFill>
+                  <a:srgbClr val="1C242E"/>
+                </a:solidFill>
+                <a:latin typeface="Microsoft YaHei"/>
+                <a:ea typeface="Microsoft YaHei"/>
+                <a:cs typeface="Microsoft YaHei"/>
+              </a:rPr>
+              <a:t>预留 6  KV 2.59  空闲 61.06 GB</a:t>
             </a:r>
           </a:p>
         </p:txBody>
@@ -13506,8 +13569,8 @@
         </p:nvSpPr>
         <p:spPr>
           <a:xfrm>
-            <a:off x="384048" y="4681728"/>
-            <a:ext cx="3529584" cy="530352"/>
+            <a:off x="384048" y="4608576"/>
+            <a:ext cx="3529584" cy="658368"/>
           </a:xfrm>
           <a:prstGeom prst="rect">
             <a:avLst/>
@@ -13671,8 +13734,8 @@
         </p:nvSpPr>
         <p:spPr>
           <a:xfrm>
-            <a:off x="4315968" y="4681728"/>
-            <a:ext cx="3529584" cy="530352"/>
+            <a:off x="4315968" y="4608576"/>
+            <a:ext cx="3529584" cy="658368"/>
           </a:xfrm>
           <a:prstGeom prst="rect">
             <a:avLst/>
@@ -13836,8 +13899,8 @@
         </p:nvSpPr>
         <p:spPr>
           <a:xfrm>
-            <a:off x="8247888" y="4681728"/>
-            <a:ext cx="3529584" cy="530352"/>
+            <a:off x="8247888" y="4608576"/>
+            <a:ext cx="3529584" cy="658368"/>
           </a:xfrm>
           <a:prstGeom prst="rect">
             <a:avLst/>

</xml_diff>